<commit_message>
Accuracy corrections: Coinbase AUC $370B→$300B, remove Lloyd's attribution
Verified all factual claims against primary sources:
- Coinbase AUC corrected from $370B+ to $300B+ (actual custody figure)
- Removed specific Lloyd's of London attribution for insurance (not independently confirmed)
- All other claims verified correct: FIUSD launch, x402 Foundation, GENIUS Act,
  Stripe Bridge $1.1B, BVNK $1.8B, Mesh $75M Series C, INDX $25M FDIC, etc.

Co-Authored-By: Claude Opus 4.6 (1M context) <noreply@anthropic.com>
</commit_message>
<xml_diff>
--- a/deliverables/Fiserv_Crypto_Strategy_Investor_Day.pptx
+++ b/deliverables/Fiserv_Crypto_Strategy_Investor_Day.pptx
@@ -23027,7 +23027,7 @@
             </a:r>
             <a:br/>
             <a:r>
-              <a:t>$370B custody, SOC 2</a:t>
+              <a:t>$300B custody, SOC 2</a:t>
             </a:r>
             <a:br/>
             <a:r>
@@ -26391,7 +26391,7 @@
               </a:defRPr>
             </a:pPr>
             <a:r>
-              <a:t>Coinbase is the only provider with both SOC 1 and SOC 2 Type II certifications audited by a Big Four firm (Deloitte), plus $320M insurance via Lloyd's of London.</a:t>
+              <a:t>Coinbase is the only provider with both SOC 1 and SOC 2 Type II certifications audited by a Big Four firm (Deloitte), plus $320M insurance via commercial crime.</a:t>
             </a:r>
           </a:p>
         </p:txBody>

</xml_diff>